<commit_message>
Updated PPT to v0.3
</commit_message>
<xml_diff>
--- a/llm101.pptx
+++ b/llm101.pptx
@@ -6865,15 +6865,19 @@
           </a:bodyPr>
           <a:lstStyle/>
           <a:p>
-            <a:pPr marL="0" lvl="0" indent="0" algn="l" rtl="0">
-              <a:spcBef>
-                <a:spcPts val="0"/>
-              </a:spcBef>
-              <a:spcAft>
-                <a:spcPts val="0"/>
-              </a:spcAft>
-              <a:buNone/>
-            </a:pPr>
+            <a:pPr lvl="0"/>
+            <a:r>
+              <a:rPr lang="en-GB" sz="1100" dirty="0">
+                <a:solidFill>
+                  <a:schemeClr val="dk2"/>
+                </a:solidFill>
+                <a:latin typeface="Roboto Mono"/>
+                <a:ea typeface="Roboto Mono"/>
+                <a:cs typeface="Roboto Mono"/>
+                <a:sym typeface="Roboto Mono"/>
+              </a:rPr>
+              <a:t># </a:t>
+            </a:r>
             <a:r>
               <a:rPr lang="en-GB" sz="1100" dirty="0" err="1">
                 <a:solidFill>
@@ -7343,7 +7347,7 @@
               <a:buNone/>
             </a:pPr>
             <a:r>
-              <a:rPr lang="en-GB" sz="900" i="1">
+              <a:rPr lang="en-GB" sz="900" dirty="0">
                 <a:solidFill>
                   <a:schemeClr val="dk1"/>
                 </a:solidFill>
@@ -7352,9 +7356,9 @@
                 <a:cs typeface="Roboto Mono"/>
                 <a:sym typeface="Roboto Mono"/>
               </a:rPr>
-              <a:t>0.2</a:t>
+              <a:t>v0.3</a:t>
             </a:r>
-            <a:endParaRPr sz="900" i="1">
+            <a:endParaRPr sz="900" dirty="0">
               <a:latin typeface="Roboto Mono"/>
               <a:ea typeface="Roboto Mono"/>
               <a:cs typeface="Roboto Mono"/>
@@ -7512,7 +7516,7 @@
                 <a:buNone/>
               </a:pPr>
               <a:r>
-                <a:rPr lang="en-GB" sz="1100">
+                <a:rPr lang="en-GB" sz="1100" dirty="0">
                   <a:solidFill>
                     <a:schemeClr val="dk2"/>
                   </a:solidFill>
@@ -7523,7 +7527,7 @@
                 </a:rPr>
                 <a:t># how models are trained</a:t>
               </a:r>
-              <a:endParaRPr sz="1100">
+              <a:endParaRPr sz="1100" dirty="0">
                 <a:solidFill>
                   <a:schemeClr val="dk2"/>
                 </a:solidFill>
@@ -7543,7 +7547,7 @@
                 </a:spcAft>
                 <a:buNone/>
               </a:pPr>
-              <a:endParaRPr sz="1100">
+              <a:endParaRPr sz="1100" dirty="0">
                 <a:solidFill>
                   <a:schemeClr val="dk2"/>
                 </a:solidFill>
@@ -7563,7 +7567,7 @@
                 </a:spcAft>
                 <a:buNone/>
               </a:pPr>
-              <a:endParaRPr sz="1100">
+              <a:endParaRPr sz="1100" dirty="0">
                 <a:solidFill>
                   <a:schemeClr val="dk2"/>
                 </a:solidFill>
@@ -7584,7 +7588,7 @@
                 <a:buNone/>
               </a:pPr>
               <a:r>
-                <a:rPr lang="en-GB" sz="1100">
+                <a:rPr lang="en-GB" sz="1100" dirty="0">
                   <a:solidFill>
                     <a:schemeClr val="dk2"/>
                   </a:solidFill>
@@ -7595,7 +7599,7 @@
                 </a:rPr>
                 <a:t>## training run</a:t>
               </a:r>
-              <a:endParaRPr sz="1100">
+              <a:endParaRPr sz="1100" dirty="0">
                 <a:solidFill>
                   <a:schemeClr val="dk2"/>
                 </a:solidFill>
@@ -7615,7 +7619,7 @@
                 </a:spcAft>
                 <a:buNone/>
               </a:pPr>
-              <a:endParaRPr sz="1100">
+              <a:endParaRPr sz="1100" dirty="0">
                 <a:solidFill>
                   <a:schemeClr val="dk2"/>
                 </a:solidFill>
@@ -7635,7 +7639,7 @@
                 </a:spcAft>
                 <a:buNone/>
               </a:pPr>
-              <a:endParaRPr sz="1100">
+              <a:endParaRPr sz="1100" dirty="0">
                 <a:solidFill>
                   <a:schemeClr val="dk2"/>
                 </a:solidFill>
@@ -7656,7 +7660,7 @@
                 <a:buNone/>
               </a:pPr>
               <a:r>
-                <a:rPr lang="en-GB" sz="1100" b="1">
+                <a:rPr lang="en-GB" sz="1100" u="sng" dirty="0">
                   <a:solidFill>
                     <a:schemeClr val="dk2"/>
                   </a:solidFill>
@@ -7668,7 +7672,7 @@
                 <a:t>weights</a:t>
               </a:r>
               <a:r>
-                <a:rPr lang="en-GB" sz="1100">
+                <a:rPr lang="en-GB" sz="1100" dirty="0">
                   <a:solidFill>
                     <a:schemeClr val="dk2"/>
                   </a:solidFill>
@@ -7679,7 +7683,7 @@
                 </a:rPr>
                 <a:t> change as token make their way through the transformer layers</a:t>
               </a:r>
-              <a:endParaRPr sz="1100">
+              <a:endParaRPr sz="1100" dirty="0">
                 <a:solidFill>
                   <a:schemeClr val="dk2"/>
                 </a:solidFill>
@@ -7700,7 +7704,7 @@
                 <a:buNone/>
               </a:pPr>
               <a:r>
-                <a:rPr lang="en-GB" sz="1100">
+                <a:rPr lang="en-GB" sz="1100" dirty="0">
                   <a:solidFill>
                     <a:schemeClr val="dk2"/>
                   </a:solidFill>
@@ -7712,7 +7716,7 @@
                 <a:t>and new </a:t>
               </a:r>
               <a:r>
-                <a:rPr lang="en-GB" sz="1100" b="1">
+                <a:rPr lang="en-GB" sz="1100" u="sng" dirty="0">
                   <a:solidFill>
                     <a:schemeClr val="dk2"/>
                   </a:solidFill>
@@ -7724,7 +7728,7 @@
                 <a:t>patterns</a:t>
               </a:r>
               <a:r>
-                <a:rPr lang="en-GB" sz="1100">
+                <a:rPr lang="en-GB" sz="1100" dirty="0">
                   <a:solidFill>
                     <a:schemeClr val="dk2"/>
                   </a:solidFill>
@@ -7733,10 +7737,34 @@
                   <a:cs typeface="Roboto Mono"/>
                   <a:sym typeface="Roboto Mono"/>
                 </a:rPr>
-                <a:t> in the data are found, similar words are clustered </a:t>
+                <a:t> in the data are found, </a:t>
               </a:r>
               <a:r>
-                <a:rPr lang="en-GB" sz="1100" b="1">
+                <a:rPr lang="en-GB" sz="1100" u="sng" dirty="0">
+                  <a:solidFill>
+                    <a:schemeClr val="dk2"/>
+                  </a:solidFill>
+                  <a:latin typeface="Roboto Mono"/>
+                  <a:ea typeface="Roboto Mono"/>
+                  <a:cs typeface="Roboto Mono"/>
+                  <a:sym typeface="Roboto Mono"/>
+                </a:rPr>
+                <a:t>semantically similar </a:t>
+              </a:r>
+              <a:r>
+                <a:rPr lang="en-GB" sz="1100" dirty="0">
+                  <a:solidFill>
+                    <a:schemeClr val="dk2"/>
+                  </a:solidFill>
+                  <a:latin typeface="Roboto Mono"/>
+                  <a:ea typeface="Roboto Mono"/>
+                  <a:cs typeface="Roboto Mono"/>
+                  <a:sym typeface="Roboto Mono"/>
+                </a:rPr>
+                <a:t>words are clustered </a:t>
+              </a:r>
+              <a:r>
+                <a:rPr lang="en-GB" sz="1100" u="sng" dirty="0">
                   <a:solidFill>
                     <a:schemeClr val="dk2"/>
                   </a:solidFill>
@@ -7748,7 +7776,7 @@
                 <a:t>closer</a:t>
               </a:r>
               <a:r>
-                <a:rPr lang="en-GB" sz="1100">
+                <a:rPr lang="en-GB" sz="1100" dirty="0">
                   <a:solidFill>
                     <a:schemeClr val="dk2"/>
                   </a:solidFill>
@@ -7759,7 +7787,7 @@
                 </a:rPr>
                 <a:t> together</a:t>
               </a:r>
-              <a:endParaRPr sz="1100">
+              <a:endParaRPr sz="1100" dirty="0">
                 <a:solidFill>
                   <a:schemeClr val="dk2"/>
                 </a:solidFill>
@@ -7779,7 +7807,7 @@
                 </a:spcAft>
                 <a:buNone/>
               </a:pPr>
-              <a:endParaRPr sz="1100">
+              <a:endParaRPr sz="1100" dirty="0">
                 <a:solidFill>
                   <a:schemeClr val="dk2"/>
                 </a:solidFill>
@@ -7800,7 +7828,7 @@
                 <a:buNone/>
               </a:pPr>
               <a:r>
-                <a:rPr lang="en-GB" sz="1100">
+                <a:rPr lang="en-GB" sz="1100" dirty="0">
                   <a:solidFill>
                     <a:schemeClr val="dk2"/>
                   </a:solidFill>
@@ -7809,12 +7837,36 @@
                   <a:cs typeface="Roboto Mono"/>
                   <a:sym typeface="Roboto Mono"/>
                 </a:rPr>
-                <a:t>"cat" → [0.823 &gt; 0.654 &gt; -0.234 &gt; 0.445 &gt; </a:t>
+                <a:t>"cat" → [</a:t>
               </a:r>
               <a:r>
-                <a:rPr lang="en-GB" sz="1100" b="1">
+                <a:rPr lang="en-GB" sz="1100" b="1" dirty="0">
+                  <a:solidFill>
+                    <a:srgbClr val="FF0000"/>
+                  </a:solidFill>
+                  <a:latin typeface="Roboto Mono"/>
+                  <a:ea typeface="Roboto Mono"/>
+                  <a:cs typeface="Roboto Mono"/>
+                  <a:sym typeface="Roboto Mono"/>
+                </a:rPr>
+                <a:t>0.823</a:t>
+              </a:r>
+              <a:r>
+                <a:rPr lang="en-GB" sz="1100" dirty="0">
                   <a:solidFill>
                     <a:schemeClr val="dk2"/>
+                  </a:solidFill>
+                  <a:latin typeface="Roboto Mono"/>
+                  <a:ea typeface="Roboto Mono"/>
+                  <a:cs typeface="Roboto Mono"/>
+                  <a:sym typeface="Roboto Mono"/>
+                </a:rPr>
+                <a:t> &gt; 0.654 &gt; -0.234 &gt; 0.445 &gt; </a:t>
+              </a:r>
+              <a:r>
+                <a:rPr lang="en-GB" sz="1100" b="1" dirty="0">
+                  <a:solidFill>
+                    <a:srgbClr val="00B050"/>
                   </a:solidFill>
                   <a:latin typeface="Roboto Mono"/>
                   <a:ea typeface="Roboto Mono"/>
@@ -7824,7 +7876,7 @@
                 <a:t>0.912</a:t>
               </a:r>
               <a:r>
-                <a:rPr lang="en-GB" sz="1100">
+                <a:rPr lang="en-GB" sz="1100" dirty="0">
                   <a:solidFill>
                     <a:schemeClr val="dk2"/>
                   </a:solidFill>
@@ -7835,7 +7887,7 @@
                 </a:rPr>
                 <a:t>]</a:t>
               </a:r>
-              <a:endParaRPr sz="1100">
+              <a:endParaRPr sz="1100" dirty="0">
                 <a:solidFill>
                   <a:schemeClr val="dk2"/>
                 </a:solidFill>
@@ -7856,7 +7908,7 @@
                 <a:buNone/>
               </a:pPr>
               <a:r>
-                <a:rPr lang="en-GB" sz="1100">
+                <a:rPr lang="en-GB" sz="1100" dirty="0">
                   <a:solidFill>
                     <a:schemeClr val="dk2"/>
                   </a:solidFill>
@@ -7865,12 +7917,36 @@
                   <a:cs typeface="Roboto Mono"/>
                   <a:sym typeface="Roboto Mono"/>
                 </a:rPr>
-                <a:t>"mat" → [1.798 &gt; 1.642 &gt; 1.210  &gt; 0.938 &gt; </a:t>
+                <a:t>"mat" → [</a:t>
               </a:r>
               <a:r>
-                <a:rPr lang="en-GB" sz="1100" b="1">
+                <a:rPr lang="en-GB" sz="1100" b="1" dirty="0">
+                  <a:solidFill>
+                    <a:srgbClr val="FF0000"/>
+                  </a:solidFill>
+                  <a:latin typeface="Roboto Mono"/>
+                  <a:ea typeface="Roboto Mono"/>
+                  <a:cs typeface="Roboto Mono"/>
+                  <a:sym typeface="Roboto Mono"/>
+                </a:rPr>
+                <a:t>1.798</a:t>
+              </a:r>
+              <a:r>
+                <a:rPr lang="en-GB" sz="1100" dirty="0">
                   <a:solidFill>
                     <a:schemeClr val="dk2"/>
+                  </a:solidFill>
+                  <a:latin typeface="Roboto Mono"/>
+                  <a:ea typeface="Roboto Mono"/>
+                  <a:cs typeface="Roboto Mono"/>
+                  <a:sym typeface="Roboto Mono"/>
+                </a:rPr>
+                <a:t> &gt; 1.642 &gt; 1.210  &gt; 0.938 &gt; </a:t>
+              </a:r>
+              <a:r>
+                <a:rPr lang="en-GB" sz="1100" b="1" dirty="0">
+                  <a:solidFill>
+                    <a:srgbClr val="00B050"/>
                   </a:solidFill>
                   <a:latin typeface="Roboto Mono"/>
                   <a:ea typeface="Roboto Mono"/>
@@ -7880,7 +7956,7 @@
                 <a:t>0.895</a:t>
               </a:r>
               <a:r>
-                <a:rPr lang="en-GB" sz="1100">
+                <a:rPr lang="en-GB" sz="1100" dirty="0">
                   <a:solidFill>
                     <a:schemeClr val="dk2"/>
                   </a:solidFill>
@@ -7891,7 +7967,7 @@
                 </a:rPr>
                 <a:t>] ← closer to "cat"</a:t>
               </a:r>
-              <a:endParaRPr sz="1100">
+              <a:endParaRPr sz="1100" dirty="0">
                 <a:solidFill>
                   <a:schemeClr val="dk2"/>
                 </a:solidFill>
@@ -7911,7 +7987,7 @@
                 </a:spcAft>
                 <a:buNone/>
               </a:pPr>
-              <a:endParaRPr sz="1100">
+              <a:endParaRPr sz="1100" dirty="0">
                 <a:solidFill>
                   <a:schemeClr val="dk2"/>
                 </a:solidFill>
@@ -8320,11 +8396,23 @@
                   <a:cs typeface="Roboto Mono"/>
                   <a:sym typeface="Roboto Mono"/>
                 </a:rPr>
-                <a:t>## semantic similarity</a:t>
+                <a:t>## </a:t>
+              </a:r>
+              <a:r>
+                <a:rPr lang="en-GB" sz="1100" dirty="0">
+                  <a:solidFill>
+                    <a:srgbClr val="FF0000"/>
+                  </a:solidFill>
+                  <a:latin typeface="Roboto Mono"/>
+                  <a:ea typeface="Roboto Mono"/>
+                  <a:cs typeface="Roboto Mono"/>
+                  <a:sym typeface="Roboto Mono"/>
+                </a:rPr>
+                <a:t>semantic similarity</a:t>
               </a:r>
               <a:endParaRPr sz="1100" dirty="0">
                 <a:solidFill>
-                  <a:schemeClr val="dk2"/>
+                  <a:srgbClr val="FF0000"/>
                 </a:solidFill>
                 <a:latin typeface="Roboto Mono"/>
                 <a:ea typeface="Roboto Mono"/>
@@ -9814,7 +9902,7 @@
                 <a:buNone/>
               </a:pPr>
               <a:r>
-                <a:rPr lang="en-GB" sz="1100">
+                <a:rPr lang="en-GB" sz="1100" dirty="0">
                   <a:solidFill>
                     <a:schemeClr val="dk2"/>
                   </a:solidFill>
@@ -9825,7 +9913,7 @@
                 </a:rPr>
                 <a:t># the history of ai</a:t>
               </a:r>
-              <a:endParaRPr sz="1100">
+              <a:endParaRPr sz="1100" dirty="0">
                 <a:solidFill>
                   <a:schemeClr val="dk2"/>
                 </a:solidFill>
@@ -9845,7 +9933,7 @@
                 </a:spcAft>
                 <a:buNone/>
               </a:pPr>
-              <a:endParaRPr sz="1100">
+              <a:endParaRPr sz="1100" dirty="0">
                 <a:solidFill>
                   <a:schemeClr val="dk2"/>
                 </a:solidFill>
@@ -9865,7 +9953,7 @@
                 </a:spcAft>
                 <a:buNone/>
               </a:pPr>
-              <a:endParaRPr sz="1100">
+              <a:endParaRPr sz="1100" dirty="0">
                 <a:solidFill>
                   <a:schemeClr val="dk2"/>
                 </a:solidFill>
@@ -9886,7 +9974,7 @@
                 <a:buNone/>
               </a:pPr>
               <a:r>
-                <a:rPr lang="en-GB" sz="1100">
+                <a:rPr lang="en-GB" sz="1100" dirty="0">
                   <a:solidFill>
                     <a:schemeClr val="dk2"/>
                   </a:solidFill>
@@ -9897,7 +9985,7 @@
                 </a:rPr>
                 <a:t>artificial intelligence</a:t>
               </a:r>
-              <a:endParaRPr sz="1100">
+              <a:endParaRPr sz="1100" dirty="0">
                 <a:solidFill>
                   <a:schemeClr val="dk2"/>
                 </a:solidFill>
@@ -9918,7 +10006,7 @@
                 <a:buNone/>
               </a:pPr>
               <a:r>
-                <a:rPr lang="en-GB" sz="1100">
+                <a:rPr lang="en-GB" sz="1100" dirty="0">
                   <a:solidFill>
                     <a:schemeClr val="dk2"/>
                   </a:solidFill>
@@ -9929,7 +10017,7 @@
                 </a:rPr>
                 <a:t>   └── machine learning</a:t>
               </a:r>
-              <a:endParaRPr sz="1100">
+              <a:endParaRPr sz="1100" dirty="0">
                 <a:solidFill>
                   <a:schemeClr val="dk2"/>
                 </a:solidFill>
@@ -9950,7 +10038,7 @@
                 <a:buNone/>
               </a:pPr>
               <a:r>
-                <a:rPr lang="en-GB" sz="1100">
+                <a:rPr lang="en-GB" sz="1100" dirty="0">
                   <a:solidFill>
                     <a:schemeClr val="dk2"/>
                   </a:solidFill>
@@ -9961,7 +10049,7 @@
                 </a:rPr>
                 <a:t>         └── deep learning</a:t>
               </a:r>
-              <a:endParaRPr sz="1100">
+              <a:endParaRPr sz="1100" dirty="0">
                 <a:solidFill>
                   <a:schemeClr val="dk2"/>
                 </a:solidFill>
@@ -9982,7 +10070,7 @@
                 <a:buNone/>
               </a:pPr>
               <a:r>
-                <a:rPr lang="en-GB" sz="1100">
+                <a:rPr lang="en-GB" sz="1100" dirty="0">
                   <a:solidFill>
                     <a:schemeClr val="dk2"/>
                   </a:solidFill>
@@ -9993,7 +10081,7 @@
                 </a:rPr>
                 <a:t>    ├── recurrent neural networks</a:t>
               </a:r>
-              <a:endParaRPr sz="1100">
+              <a:endParaRPr sz="1100" dirty="0">
                 <a:solidFill>
                   <a:schemeClr val="dk2"/>
                 </a:solidFill>
@@ -10014,7 +10102,7 @@
                 <a:buNone/>
               </a:pPr>
               <a:r>
-                <a:rPr lang="en-GB" sz="1100">
+                <a:rPr lang="en-GB" sz="1100" dirty="0">
                   <a:solidFill>
                     <a:schemeClr val="dk2"/>
                   </a:solidFill>
@@ -10025,7 +10113,7 @@
                 </a:rPr>
                 <a:t>               └── foundational models  </a:t>
               </a:r>
-              <a:endParaRPr sz="1100">
+              <a:endParaRPr sz="1100" dirty="0">
                 <a:solidFill>
                   <a:schemeClr val="dk2"/>
                 </a:solidFill>
@@ -10046,7 +10134,7 @@
                 <a:buNone/>
               </a:pPr>
               <a:r>
-                <a:rPr lang="en-GB" sz="1100">
+                <a:rPr lang="en-GB" sz="1100" dirty="0">
                   <a:solidFill>
                     <a:schemeClr val="dk2"/>
                   </a:solidFill>
@@ -10057,7 +10145,7 @@
                 </a:rPr>
                 <a:t>                     ├── large language models</a:t>
               </a:r>
-              <a:endParaRPr sz="1100">
+              <a:endParaRPr sz="1100" dirty="0">
                 <a:solidFill>
                   <a:schemeClr val="dk2"/>
                 </a:solidFill>
@@ -10078,7 +10166,7 @@
                 <a:buNone/>
               </a:pPr>
               <a:r>
-                <a:rPr lang="en-GB" sz="1100">
+                <a:rPr lang="en-GB" sz="1100" dirty="0">
                   <a:solidFill>
                     <a:schemeClr val="dk2"/>
                   </a:solidFill>
@@ -10089,7 +10177,7 @@
                 </a:rPr>
                 <a:t>                     ├── vision models  </a:t>
               </a:r>
-              <a:endParaRPr sz="1100">
+              <a:endParaRPr sz="1100" dirty="0">
                 <a:solidFill>
                   <a:schemeClr val="dk2"/>
                 </a:solidFill>
@@ -10110,7 +10198,7 @@
                 <a:buNone/>
               </a:pPr>
               <a:r>
-                <a:rPr lang="en-GB" sz="1100">
+                <a:rPr lang="en-GB" sz="1100" dirty="0">
                   <a:solidFill>
                     <a:schemeClr val="dk2"/>
                   </a:solidFill>
@@ -10121,7 +10209,7 @@
                 </a:rPr>
                 <a:t>                     ├── speech models  </a:t>
               </a:r>
-              <a:endParaRPr sz="1100">
+              <a:endParaRPr sz="1100" dirty="0">
                 <a:solidFill>
                   <a:schemeClr val="dk2"/>
                 </a:solidFill>
@@ -10142,7 +10230,7 @@
                 <a:buNone/>
               </a:pPr>
               <a:r>
-                <a:rPr lang="en-GB" sz="1100">
+                <a:rPr lang="en-GB" sz="1100" dirty="0">
                   <a:solidFill>
                     <a:schemeClr val="dk2"/>
                   </a:solidFill>
@@ -10153,7 +10241,7 @@
                 </a:rPr>
                 <a:t>                     └── multimodal models  </a:t>
               </a:r>
-              <a:endParaRPr sz="1100">
+              <a:endParaRPr sz="1100" dirty="0">
                 <a:solidFill>
                   <a:schemeClr val="dk2"/>
                 </a:solidFill>
@@ -10174,7 +10262,7 @@
                 <a:buNone/>
               </a:pPr>
               <a:r>
-                <a:rPr lang="en-GB" sz="1100">
+                <a:rPr lang="en-GB" sz="1100" dirty="0">
                   <a:solidFill>
                     <a:schemeClr val="dk2"/>
                   </a:solidFill>
@@ -10185,7 +10273,7 @@
                 </a:rPr>
                 <a:t>                           └── agentic ai [built on top]</a:t>
               </a:r>
-              <a:endParaRPr sz="1100">
+              <a:endParaRPr sz="1100" dirty="0">
                 <a:solidFill>
                   <a:schemeClr val="dk2"/>
                 </a:solidFill>
@@ -10205,7 +10293,7 @@
                 </a:spcAft>
                 <a:buNone/>
               </a:pPr>
-              <a:endParaRPr sz="1100">
+              <a:endParaRPr sz="1100" dirty="0">
                 <a:solidFill>
                   <a:schemeClr val="dk2"/>
                 </a:solidFill>

</xml_diff>

<commit_message>
Updated PPT to v0.4
</commit_message>
<xml_diff>
--- a/llm101.pptx
+++ b/llm101.pptx
@@ -9,8 +9,8 @@
   </p:notesMasterIdLst>
   <p:sldIdLst>
     <p:sldId id="256" r:id="rId2"/>
-    <p:sldId id="257" r:id="rId3"/>
-    <p:sldId id="258" r:id="rId4"/>
+    <p:sldId id="258" r:id="rId3"/>
+    <p:sldId id="257" r:id="rId4"/>
     <p:sldId id="260" r:id="rId5"/>
     <p:sldId id="259" r:id="rId6"/>
     <p:sldId id="261" r:id="rId7"/>
@@ -1375,6 +1375,110 @@
   <p:cSld>
     <p:spTree>
       <p:nvGrpSpPr>
+        <p:cNvPr id="1" name="Shape 68"/>
+        <p:cNvGrpSpPr/>
+        <p:nvPr/>
+      </p:nvGrpSpPr>
+      <p:grpSpPr>
+        <a:xfrm>
+          <a:off x="0" y="0"/>
+          <a:ext cx="0" cy="0"/>
+          <a:chOff x="0" y="0"/>
+          <a:chExt cx="0" cy="0"/>
+        </a:xfrm>
+      </p:grpSpPr>
+      <p:sp>
+        <p:nvSpPr>
+          <p:cNvPr id="69" name="Google Shape;69;g3b8be81d937_0_92:notes"/>
+          <p:cNvSpPr>
+            <a:spLocks noGrp="1" noRot="1" noChangeAspect="1"/>
+          </p:cNvSpPr>
+          <p:nvPr>
+            <p:ph type="sldImg" idx="2"/>
+          </p:nvPr>
+        </p:nvSpPr>
+        <p:spPr>
+          <a:xfrm>
+            <a:off x="381000" y="685800"/>
+            <a:ext cx="6096000" cy="3429000"/>
+          </a:xfrm>
+          <a:custGeom>
+            <a:avLst/>
+            <a:gdLst/>
+            <a:ahLst/>
+            <a:cxnLst/>
+            <a:rect l="l" t="t" r="r" b="b"/>
+            <a:pathLst>
+              <a:path w="120000" h="120000" extrusionOk="0">
+                <a:moveTo>
+                  <a:pt x="0" y="0"/>
+                </a:moveTo>
+                <a:lnTo>
+                  <a:pt x="120000" y="0"/>
+                </a:lnTo>
+                <a:lnTo>
+                  <a:pt x="120000" y="120000"/>
+                </a:lnTo>
+                <a:lnTo>
+                  <a:pt x="0" y="120000"/>
+                </a:lnTo>
+                <a:close/>
+              </a:path>
+            </a:pathLst>
+          </a:custGeom>
+        </p:spPr>
+      </p:sp>
+      <p:sp>
+        <p:nvSpPr>
+          <p:cNvPr id="70" name="Google Shape;70;g3b8be81d937_0_92:notes"/>
+          <p:cNvSpPr txBox="1">
+            <a:spLocks noGrp="1"/>
+          </p:cNvSpPr>
+          <p:nvPr>
+            <p:ph type="body" idx="1"/>
+          </p:nvPr>
+        </p:nvSpPr>
+        <p:spPr>
+          <a:xfrm>
+            <a:off x="685800" y="4343400"/>
+            <a:ext cx="5486400" cy="4114800"/>
+          </a:xfrm>
+          <a:prstGeom prst="rect">
+            <a:avLst/>
+          </a:prstGeom>
+        </p:spPr>
+        <p:txBody>
+          <a:bodyPr spcFirstLastPara="1" wrap="square" lIns="91425" tIns="91425" rIns="91425" bIns="91425" anchor="t" anchorCtr="0">
+            <a:noAutofit/>
+          </a:bodyPr>
+          <a:lstStyle/>
+          <a:p>
+            <a:pPr marL="0" lvl="0" indent="0" algn="l" rtl="0">
+              <a:spcBef>
+                <a:spcPts val="0"/>
+              </a:spcBef>
+              <a:spcAft>
+                <a:spcPts val="0"/>
+              </a:spcAft>
+              <a:buNone/>
+            </a:pPr>
+            <a:endParaRPr/>
+          </a:p>
+        </p:txBody>
+      </p:sp>
+    </p:spTree>
+  </p:cSld>
+  <p:clrMapOvr>
+    <a:masterClrMapping/>
+  </p:clrMapOvr>
+</p:notes>
+</file>
+
+<file path=ppt/notesSlides/notesSlide3.xml><?xml version="1.0" encoding="utf-8"?>
+<p:notes xmlns:a="http://schemas.openxmlformats.org/drawingml/2006/main" xmlns:r="http://schemas.openxmlformats.org/officeDocument/2006/relationships" xmlns:p="http://schemas.openxmlformats.org/presentationml/2006/main" showMasterSp="0" showMasterPhAnim="0">
+  <p:cSld>
+    <p:spTree>
+      <p:nvGrpSpPr>
         <p:cNvPr id="1" name="Shape 59"/>
         <p:cNvGrpSpPr/>
         <p:nvPr/>
@@ -1431,110 +1535,6 @@
       <p:sp>
         <p:nvSpPr>
           <p:cNvPr id="61" name="Google Shape;61;g3b8be81d937_0_25:notes"/>
-          <p:cNvSpPr txBox="1">
-            <a:spLocks noGrp="1"/>
-          </p:cNvSpPr>
-          <p:nvPr>
-            <p:ph type="body" idx="1"/>
-          </p:nvPr>
-        </p:nvSpPr>
-        <p:spPr>
-          <a:xfrm>
-            <a:off x="685800" y="4343400"/>
-            <a:ext cx="5486400" cy="4114800"/>
-          </a:xfrm>
-          <a:prstGeom prst="rect">
-            <a:avLst/>
-          </a:prstGeom>
-        </p:spPr>
-        <p:txBody>
-          <a:bodyPr spcFirstLastPara="1" wrap="square" lIns="91425" tIns="91425" rIns="91425" bIns="91425" anchor="t" anchorCtr="0">
-            <a:noAutofit/>
-          </a:bodyPr>
-          <a:lstStyle/>
-          <a:p>
-            <a:pPr marL="0" lvl="0" indent="0" algn="l" rtl="0">
-              <a:spcBef>
-                <a:spcPts val="0"/>
-              </a:spcBef>
-              <a:spcAft>
-                <a:spcPts val="0"/>
-              </a:spcAft>
-              <a:buNone/>
-            </a:pPr>
-            <a:endParaRPr/>
-          </a:p>
-        </p:txBody>
-      </p:sp>
-    </p:spTree>
-  </p:cSld>
-  <p:clrMapOvr>
-    <a:masterClrMapping/>
-  </p:clrMapOvr>
-</p:notes>
-</file>
-
-<file path=ppt/notesSlides/notesSlide3.xml><?xml version="1.0" encoding="utf-8"?>
-<p:notes xmlns:a="http://schemas.openxmlformats.org/drawingml/2006/main" xmlns:r="http://schemas.openxmlformats.org/officeDocument/2006/relationships" xmlns:p="http://schemas.openxmlformats.org/presentationml/2006/main" showMasterSp="0" showMasterPhAnim="0">
-  <p:cSld>
-    <p:spTree>
-      <p:nvGrpSpPr>
-        <p:cNvPr id="1" name="Shape 68"/>
-        <p:cNvGrpSpPr/>
-        <p:nvPr/>
-      </p:nvGrpSpPr>
-      <p:grpSpPr>
-        <a:xfrm>
-          <a:off x="0" y="0"/>
-          <a:ext cx="0" cy="0"/>
-          <a:chOff x="0" y="0"/>
-          <a:chExt cx="0" cy="0"/>
-        </a:xfrm>
-      </p:grpSpPr>
-      <p:sp>
-        <p:nvSpPr>
-          <p:cNvPr id="69" name="Google Shape;69;g3b8be81d937_0_92:notes"/>
-          <p:cNvSpPr>
-            <a:spLocks noGrp="1" noRot="1" noChangeAspect="1"/>
-          </p:cNvSpPr>
-          <p:nvPr>
-            <p:ph type="sldImg" idx="2"/>
-          </p:nvPr>
-        </p:nvSpPr>
-        <p:spPr>
-          <a:xfrm>
-            <a:off x="381000" y="685800"/>
-            <a:ext cx="6096000" cy="3429000"/>
-          </a:xfrm>
-          <a:custGeom>
-            <a:avLst/>
-            <a:gdLst/>
-            <a:ahLst/>
-            <a:cxnLst/>
-            <a:rect l="l" t="t" r="r" b="b"/>
-            <a:pathLst>
-              <a:path w="120000" h="120000" extrusionOk="0">
-                <a:moveTo>
-                  <a:pt x="0" y="0"/>
-                </a:moveTo>
-                <a:lnTo>
-                  <a:pt x="120000" y="0"/>
-                </a:lnTo>
-                <a:lnTo>
-                  <a:pt x="120000" y="120000"/>
-                </a:lnTo>
-                <a:lnTo>
-                  <a:pt x="0" y="120000"/>
-                </a:lnTo>
-                <a:close/>
-              </a:path>
-            </a:pathLst>
-          </a:custGeom>
-        </p:spPr>
-      </p:sp>
-      <p:sp>
-        <p:nvSpPr>
-          <p:cNvPr id="70" name="Google Shape;70;g3b8be81d937_0_92:notes"/>
           <p:cNvSpPr txBox="1">
             <a:spLocks noGrp="1"/>
           </p:cNvSpPr>
@@ -7484,7 +7484,7 @@
                 <a:cs typeface="Roboto Mono"/>
                 <a:sym typeface="Roboto Mono"/>
               </a:rPr>
-              <a:t>v0.3</a:t>
+              <a:t>v0.4</a:t>
             </a:r>
             <a:endParaRPr sz="900" dirty="0">
               <a:latin typeface="Roboto Mono"/>
@@ -10427,6 +10427,273 @@
   <p:cSld>
     <p:spTree>
       <p:nvGrpSpPr>
+        <p:cNvPr id="1" name="Shape 71"/>
+        <p:cNvGrpSpPr/>
+        <p:nvPr/>
+      </p:nvGrpSpPr>
+      <p:grpSpPr>
+        <a:xfrm>
+          <a:off x="0" y="0"/>
+          <a:ext cx="0" cy="0"/>
+          <a:chOff x="0" y="0"/>
+          <a:chExt cx="0" cy="0"/>
+        </a:xfrm>
+      </p:grpSpPr>
+      <p:sp>
+        <p:nvSpPr>
+          <p:cNvPr id="72" name="Google Shape;72;p15"/>
+          <p:cNvSpPr txBox="1"/>
+          <p:nvPr/>
+        </p:nvSpPr>
+        <p:spPr>
+          <a:xfrm>
+            <a:off x="389250" y="2600850"/>
+            <a:ext cx="8365500" cy="2219100"/>
+          </a:xfrm>
+          <a:prstGeom prst="rect">
+            <a:avLst/>
+          </a:prstGeom>
+          <a:noFill/>
+          <a:ln>
+            <a:noFill/>
+          </a:ln>
+        </p:spPr>
+        <p:txBody>
+          <a:bodyPr spcFirstLastPara="1" wrap="square" lIns="91425" tIns="91425" rIns="91425" bIns="91425" anchor="t" anchorCtr="0">
+            <a:noAutofit/>
+          </a:bodyPr>
+          <a:lstStyle/>
+          <a:p>
+            <a:pPr marL="0" lvl="0" indent="0" algn="l" rtl="0">
+              <a:spcBef>
+                <a:spcPts val="0"/>
+              </a:spcBef>
+              <a:spcAft>
+                <a:spcPts val="0"/>
+              </a:spcAft>
+              <a:buNone/>
+            </a:pPr>
+            <a:r>
+              <a:rPr lang="en-GB" sz="1100" dirty="0">
+                <a:solidFill>
+                  <a:schemeClr val="dk2"/>
+                </a:solidFill>
+                <a:latin typeface="Roboto Mono"/>
+                <a:ea typeface="Roboto Mono"/>
+                <a:cs typeface="Roboto Mono"/>
+                <a:sym typeface="Roboto Mono"/>
+              </a:rPr>
+              <a:t># [cheat-code] everything that follows is not text memorisation, </a:t>
+            </a:r>
+            <a:r>
+              <a:rPr lang="en-GB" sz="1100" b="1" dirty="0">
+                <a:solidFill>
+                  <a:schemeClr val="dk2"/>
+                </a:solidFill>
+                <a:latin typeface="Roboto Mono"/>
+                <a:ea typeface="Roboto Mono"/>
+                <a:cs typeface="Roboto Mono"/>
+                <a:sym typeface="Roboto Mono"/>
+              </a:rPr>
+              <a:t>it's pattern recognition!</a:t>
+            </a:r>
+            <a:endParaRPr sz="1100" b="1" dirty="0">
+              <a:solidFill>
+                <a:schemeClr val="dk2"/>
+              </a:solidFill>
+              <a:latin typeface="Roboto Mono"/>
+              <a:ea typeface="Roboto Mono"/>
+              <a:cs typeface="Roboto Mono"/>
+              <a:sym typeface="Roboto Mono"/>
+            </a:endParaRPr>
+          </a:p>
+        </p:txBody>
+      </p:sp>
+      <p:sp>
+        <p:nvSpPr>
+          <p:cNvPr id="73" name="Google Shape;73;p15"/>
+          <p:cNvSpPr txBox="1"/>
+          <p:nvPr/>
+        </p:nvSpPr>
+        <p:spPr>
+          <a:xfrm>
+            <a:off x="2633225" y="407600"/>
+            <a:ext cx="3726600" cy="461700"/>
+          </a:xfrm>
+          <a:prstGeom prst="rect">
+            <a:avLst/>
+          </a:prstGeom>
+          <a:noFill/>
+          <a:ln>
+            <a:noFill/>
+          </a:ln>
+        </p:spPr>
+        <p:txBody>
+          <a:bodyPr spcFirstLastPara="1" wrap="square" lIns="91425" tIns="91425" rIns="91425" bIns="91425" anchor="t" anchorCtr="0">
+            <a:spAutoFit/>
+          </a:bodyPr>
+          <a:lstStyle/>
+          <a:p>
+            <a:pPr marL="0" lvl="0" indent="0" algn="l" rtl="0">
+              <a:spcBef>
+                <a:spcPts val="0"/>
+              </a:spcBef>
+              <a:spcAft>
+                <a:spcPts val="0"/>
+              </a:spcAft>
+              <a:buNone/>
+            </a:pPr>
+            <a:endParaRPr sz="1800">
+              <a:solidFill>
+                <a:schemeClr val="dk2"/>
+              </a:solidFill>
+            </a:endParaRPr>
+          </a:p>
+        </p:txBody>
+      </p:sp>
+      <p:sp>
+        <p:nvSpPr>
+          <p:cNvPr id="74" name="Google Shape;74;p15"/>
+          <p:cNvSpPr txBox="1"/>
+          <p:nvPr/>
+        </p:nvSpPr>
+        <p:spPr>
+          <a:xfrm>
+            <a:off x="313775" y="4690625"/>
+            <a:ext cx="8365500" cy="377700"/>
+          </a:xfrm>
+          <a:prstGeom prst="rect">
+            <a:avLst/>
+          </a:prstGeom>
+          <a:noFill/>
+          <a:ln>
+            <a:noFill/>
+          </a:ln>
+        </p:spPr>
+        <p:txBody>
+          <a:bodyPr spcFirstLastPara="1" wrap="square" lIns="91425" tIns="91425" rIns="91425" bIns="91425" anchor="t" anchorCtr="0">
+            <a:noAutofit/>
+          </a:bodyPr>
+          <a:lstStyle/>
+          <a:p>
+            <a:pPr lvl="0" algn="r">
+              <a:buClr>
+                <a:schemeClr val="dk1"/>
+              </a:buClr>
+              <a:buSzPts val="1100"/>
+            </a:pPr>
+            <a:r>
+              <a:rPr lang="en-GB" sz="800" dirty="0">
+                <a:solidFill>
+                  <a:schemeClr val="dk1"/>
+                </a:solidFill>
+                <a:latin typeface="Roboto Mono"/>
+                <a:ea typeface="Roboto Mono"/>
+                <a:cs typeface="Roboto Mono"/>
+                <a:sym typeface="Roboto Mono"/>
+              </a:rPr>
+              <a:t>dean.lawrence@avanade.com</a:t>
+            </a:r>
+          </a:p>
+          <a:p>
+            <a:pPr lvl="0" algn="r">
+              <a:buClr>
+                <a:schemeClr val="dk1"/>
+              </a:buClr>
+              <a:buSzPts val="1100"/>
+            </a:pPr>
+            <a:r>
+              <a:rPr lang="en-GB" sz="800" dirty="0">
+                <a:solidFill>
+                  <a:schemeClr val="dk1"/>
+                </a:solidFill>
+                <a:latin typeface="Roboto Mono"/>
+                <a:ea typeface="Roboto Mono"/>
+                <a:cs typeface="Roboto Mono"/>
+                <a:sym typeface="Roboto Mono"/>
+              </a:rPr>
+              <a:t>github.com/deanl1982/llm101</a:t>
+            </a:r>
+          </a:p>
+          <a:p>
+            <a:pPr lvl="0" algn="ctr"/>
+            <a:endParaRPr lang="en-GB" sz="800" dirty="0">
+              <a:latin typeface="Roboto Mono"/>
+              <a:ea typeface="Roboto Mono"/>
+              <a:cs typeface="Roboto Mono"/>
+              <a:sym typeface="Roboto Mono"/>
+            </a:endParaRPr>
+          </a:p>
+        </p:txBody>
+      </p:sp>
+      <p:sp>
+        <p:nvSpPr>
+          <p:cNvPr id="75" name="Google Shape;75;p15"/>
+          <p:cNvSpPr txBox="1"/>
+          <p:nvPr/>
+        </p:nvSpPr>
+        <p:spPr>
+          <a:xfrm>
+            <a:off x="427025" y="2138650"/>
+            <a:ext cx="8365500" cy="377700"/>
+          </a:xfrm>
+          <a:prstGeom prst="rect">
+            <a:avLst/>
+          </a:prstGeom>
+          <a:noFill/>
+          <a:ln>
+            <a:noFill/>
+          </a:ln>
+        </p:spPr>
+        <p:txBody>
+          <a:bodyPr spcFirstLastPara="1" wrap="square" lIns="91425" tIns="91425" rIns="91425" bIns="91425" anchor="t" anchorCtr="0">
+            <a:noAutofit/>
+          </a:bodyPr>
+          <a:lstStyle/>
+          <a:p>
+            <a:pPr marL="0" lvl="0" indent="0" algn="l" rtl="0">
+              <a:spcBef>
+                <a:spcPts val="0"/>
+              </a:spcBef>
+              <a:spcAft>
+                <a:spcPts val="0"/>
+              </a:spcAft>
+              <a:buNone/>
+            </a:pPr>
+            <a:r>
+              <a:rPr lang="en-GB" sz="1200" b="1" i="1">
+                <a:latin typeface="Roboto Mono"/>
+                <a:ea typeface="Roboto Mono"/>
+                <a:cs typeface="Roboto Mono"/>
+                <a:sym typeface="Roboto Mono"/>
+              </a:rPr>
+              <a:t>ai-101</a:t>
+            </a:r>
+            <a:endParaRPr sz="1200" b="1" i="1">
+              <a:solidFill>
+                <a:schemeClr val="dk2"/>
+              </a:solidFill>
+              <a:latin typeface="Roboto Mono"/>
+              <a:ea typeface="Roboto Mono"/>
+              <a:cs typeface="Roboto Mono"/>
+              <a:sym typeface="Roboto Mono"/>
+            </a:endParaRPr>
+          </a:p>
+        </p:txBody>
+      </p:sp>
+    </p:spTree>
+  </p:cSld>
+  <p:clrMapOvr>
+    <a:masterClrMapping/>
+  </p:clrMapOvr>
+</p:sld>
+</file>
+
+<file path=ppt/slides/slide3.xml><?xml version="1.0" encoding="utf-8"?>
+<p:sld xmlns:a="http://schemas.openxmlformats.org/drawingml/2006/main" xmlns:r="http://schemas.openxmlformats.org/officeDocument/2006/relationships" xmlns:p="http://schemas.openxmlformats.org/presentationml/2006/main">
+  <p:cSld>
+    <p:spTree>
+      <p:nvGrpSpPr>
         <p:cNvPr id="1" name="Shape 62"/>
         <p:cNvGrpSpPr/>
         <p:nvPr/>
@@ -10497,7 +10764,7 @@
                   <a:cs typeface="Roboto Mono"/>
                   <a:sym typeface="Roboto Mono"/>
                 </a:rPr>
-                <a:t># the history of ai</a:t>
+                <a:t># the brief history of ai</a:t>
               </a:r>
             </a:p>
             <a:p>
@@ -10655,7 +10922,19 @@
                   <a:cs typeface="Roboto Mono"/>
                   <a:sym typeface="Roboto Mono"/>
                 </a:rPr>
-                <a:t>                       └── transformers</a:t>
+                <a:t>                       └── </a:t>
+              </a:r>
+              <a:r>
+                <a:rPr lang="en-GB" sz="1100" b="1" dirty="0">
+                  <a:solidFill>
+                    <a:srgbClr val="FF0000"/>
+                  </a:solidFill>
+                  <a:latin typeface="Roboto Mono"/>
+                  <a:ea typeface="Roboto Mono"/>
+                  <a:cs typeface="Roboto Mono"/>
+                  <a:sym typeface="Roboto Mono"/>
+                </a:rPr>
+                <a:t>transformers</a:t>
               </a:r>
             </a:p>
             <a:p>
@@ -10971,345 +11250,6 @@
           </p:txBody>
         </p:sp>
       </p:grpSp>
-    </p:spTree>
-  </p:cSld>
-  <p:clrMapOvr>
-    <a:masterClrMapping/>
-  </p:clrMapOvr>
-</p:sld>
-</file>
-
-<file path=ppt/slides/slide3.xml><?xml version="1.0" encoding="utf-8"?>
-<p:sld xmlns:a="http://schemas.openxmlformats.org/drawingml/2006/main" xmlns:r="http://schemas.openxmlformats.org/officeDocument/2006/relationships" xmlns:p="http://schemas.openxmlformats.org/presentationml/2006/main">
-  <p:cSld>
-    <p:spTree>
-      <p:nvGrpSpPr>
-        <p:cNvPr id="1" name="Shape 71"/>
-        <p:cNvGrpSpPr/>
-        <p:nvPr/>
-      </p:nvGrpSpPr>
-      <p:grpSpPr>
-        <a:xfrm>
-          <a:off x="0" y="0"/>
-          <a:ext cx="0" cy="0"/>
-          <a:chOff x="0" y="0"/>
-          <a:chExt cx="0" cy="0"/>
-        </a:xfrm>
-      </p:grpSpPr>
-      <p:sp>
-        <p:nvSpPr>
-          <p:cNvPr id="72" name="Google Shape;72;p15"/>
-          <p:cNvSpPr txBox="1"/>
-          <p:nvPr/>
-        </p:nvSpPr>
-        <p:spPr>
-          <a:xfrm>
-            <a:off x="389250" y="2600850"/>
-            <a:ext cx="8365500" cy="2219100"/>
-          </a:xfrm>
-          <a:prstGeom prst="rect">
-            <a:avLst/>
-          </a:prstGeom>
-          <a:noFill/>
-          <a:ln>
-            <a:noFill/>
-          </a:ln>
-        </p:spPr>
-        <p:txBody>
-          <a:bodyPr spcFirstLastPara="1" wrap="square" lIns="91425" tIns="91425" rIns="91425" bIns="91425" anchor="t" anchorCtr="0">
-            <a:noAutofit/>
-          </a:bodyPr>
-          <a:lstStyle/>
-          <a:p>
-            <a:pPr marL="0" lvl="0" indent="0" algn="l" rtl="0">
-              <a:spcBef>
-                <a:spcPts val="0"/>
-              </a:spcBef>
-              <a:spcAft>
-                <a:spcPts val="0"/>
-              </a:spcAft>
-              <a:buNone/>
-            </a:pPr>
-            <a:r>
-              <a:rPr lang="en-GB" sz="1100" dirty="0">
-                <a:solidFill>
-                  <a:schemeClr val="dk2"/>
-                </a:solidFill>
-                <a:latin typeface="Roboto Mono"/>
-                <a:ea typeface="Roboto Mono"/>
-                <a:cs typeface="Roboto Mono"/>
-                <a:sym typeface="Roboto Mono"/>
-              </a:rPr>
-              <a:t># how models are trained</a:t>
-            </a:r>
-            <a:endParaRPr sz="1100" dirty="0">
-              <a:solidFill>
-                <a:schemeClr val="dk2"/>
-              </a:solidFill>
-              <a:latin typeface="Roboto Mono"/>
-              <a:ea typeface="Roboto Mono"/>
-              <a:cs typeface="Roboto Mono"/>
-              <a:sym typeface="Roboto Mono"/>
-            </a:endParaRPr>
-          </a:p>
-          <a:p>
-            <a:pPr marL="0" lvl="0" indent="0" algn="l" rtl="0">
-              <a:spcBef>
-                <a:spcPts val="0"/>
-              </a:spcBef>
-              <a:spcAft>
-                <a:spcPts val="0"/>
-              </a:spcAft>
-              <a:buNone/>
-            </a:pPr>
-            <a:endParaRPr sz="1100" dirty="0">
-              <a:solidFill>
-                <a:schemeClr val="dk2"/>
-              </a:solidFill>
-              <a:latin typeface="Roboto Mono"/>
-              <a:ea typeface="Roboto Mono"/>
-              <a:cs typeface="Roboto Mono"/>
-              <a:sym typeface="Roboto Mono"/>
-            </a:endParaRPr>
-          </a:p>
-          <a:p>
-            <a:pPr marL="0" lvl="0" indent="0" algn="l" rtl="0">
-              <a:spcBef>
-                <a:spcPts val="0"/>
-              </a:spcBef>
-              <a:spcAft>
-                <a:spcPts val="0"/>
-              </a:spcAft>
-              <a:buNone/>
-            </a:pPr>
-            <a:endParaRPr sz="1100" dirty="0">
-              <a:solidFill>
-                <a:schemeClr val="dk2"/>
-              </a:solidFill>
-              <a:latin typeface="Roboto Mono"/>
-              <a:ea typeface="Roboto Mono"/>
-              <a:cs typeface="Roboto Mono"/>
-              <a:sym typeface="Roboto Mono"/>
-            </a:endParaRPr>
-          </a:p>
-          <a:p>
-            <a:pPr marL="0" lvl="0" indent="0" algn="l" rtl="0">
-              <a:spcBef>
-                <a:spcPts val="0"/>
-              </a:spcBef>
-              <a:spcAft>
-                <a:spcPts val="0"/>
-              </a:spcAft>
-              <a:buNone/>
-            </a:pPr>
-            <a:r>
-              <a:rPr lang="en-GB" sz="1100" dirty="0">
-                <a:solidFill>
-                  <a:schemeClr val="dk2"/>
-                </a:solidFill>
-                <a:latin typeface="Roboto Mono"/>
-                <a:ea typeface="Roboto Mono"/>
-                <a:cs typeface="Roboto Mono"/>
-                <a:sym typeface="Roboto Mono"/>
-              </a:rPr>
-              <a:t>## [cheat-code ] everything that follows is not text memorisation, </a:t>
-            </a:r>
-            <a:r>
-              <a:rPr lang="en-GB" sz="1100" b="1" dirty="0">
-                <a:solidFill>
-                  <a:schemeClr val="dk2"/>
-                </a:solidFill>
-                <a:latin typeface="Roboto Mono"/>
-                <a:ea typeface="Roboto Mono"/>
-                <a:cs typeface="Roboto Mono"/>
-                <a:sym typeface="Roboto Mono"/>
-              </a:rPr>
-              <a:t>it's pattern recognition!</a:t>
-            </a:r>
-            <a:endParaRPr sz="1100" b="1" dirty="0">
-              <a:solidFill>
-                <a:schemeClr val="dk2"/>
-              </a:solidFill>
-              <a:latin typeface="Roboto Mono"/>
-              <a:ea typeface="Roboto Mono"/>
-              <a:cs typeface="Roboto Mono"/>
-              <a:sym typeface="Roboto Mono"/>
-            </a:endParaRPr>
-          </a:p>
-        </p:txBody>
-      </p:sp>
-      <p:sp>
-        <p:nvSpPr>
-          <p:cNvPr id="73" name="Google Shape;73;p15"/>
-          <p:cNvSpPr txBox="1"/>
-          <p:nvPr/>
-        </p:nvSpPr>
-        <p:spPr>
-          <a:xfrm>
-            <a:off x="2633225" y="407600"/>
-            <a:ext cx="3726600" cy="461700"/>
-          </a:xfrm>
-          <a:prstGeom prst="rect">
-            <a:avLst/>
-          </a:prstGeom>
-          <a:noFill/>
-          <a:ln>
-            <a:noFill/>
-          </a:ln>
-        </p:spPr>
-        <p:txBody>
-          <a:bodyPr spcFirstLastPara="1" wrap="square" lIns="91425" tIns="91425" rIns="91425" bIns="91425" anchor="t" anchorCtr="0">
-            <a:spAutoFit/>
-          </a:bodyPr>
-          <a:lstStyle/>
-          <a:p>
-            <a:pPr marL="0" lvl="0" indent="0" algn="l" rtl="0">
-              <a:spcBef>
-                <a:spcPts val="0"/>
-              </a:spcBef>
-              <a:spcAft>
-                <a:spcPts val="0"/>
-              </a:spcAft>
-              <a:buNone/>
-            </a:pPr>
-            <a:endParaRPr sz="1800">
-              <a:solidFill>
-                <a:schemeClr val="dk2"/>
-              </a:solidFill>
-            </a:endParaRPr>
-          </a:p>
-        </p:txBody>
-      </p:sp>
-      <p:sp>
-        <p:nvSpPr>
-          <p:cNvPr id="74" name="Google Shape;74;p15"/>
-          <p:cNvSpPr txBox="1"/>
-          <p:nvPr/>
-        </p:nvSpPr>
-        <p:spPr>
-          <a:xfrm>
-            <a:off x="313775" y="4690625"/>
-            <a:ext cx="8365500" cy="377700"/>
-          </a:xfrm>
-          <a:prstGeom prst="rect">
-            <a:avLst/>
-          </a:prstGeom>
-          <a:noFill/>
-          <a:ln>
-            <a:noFill/>
-          </a:ln>
-        </p:spPr>
-        <p:txBody>
-          <a:bodyPr spcFirstLastPara="1" wrap="square" lIns="91425" tIns="91425" rIns="91425" bIns="91425" anchor="t" anchorCtr="0">
-            <a:noAutofit/>
-          </a:bodyPr>
-          <a:lstStyle/>
-          <a:p>
-            <a:pPr lvl="0" algn="r">
-              <a:buClr>
-                <a:schemeClr val="dk1"/>
-              </a:buClr>
-              <a:buSzPts val="1100"/>
-            </a:pPr>
-            <a:r>
-              <a:rPr lang="en-GB" sz="800" dirty="0">
-                <a:solidFill>
-                  <a:schemeClr val="dk1"/>
-                </a:solidFill>
-                <a:latin typeface="Roboto Mono"/>
-                <a:ea typeface="Roboto Mono"/>
-                <a:cs typeface="Roboto Mono"/>
-                <a:sym typeface="Roboto Mono"/>
-              </a:rPr>
-              <a:t>dean.lawrence@avanade.com</a:t>
-            </a:r>
-          </a:p>
-          <a:p>
-            <a:pPr lvl="0" algn="r">
-              <a:buClr>
-                <a:schemeClr val="dk1"/>
-              </a:buClr>
-              <a:buSzPts val="1100"/>
-            </a:pPr>
-            <a:r>
-              <a:rPr lang="en-GB" sz="800" dirty="0">
-                <a:solidFill>
-                  <a:schemeClr val="dk1"/>
-                </a:solidFill>
-                <a:latin typeface="Roboto Mono"/>
-                <a:ea typeface="Roboto Mono"/>
-                <a:cs typeface="Roboto Mono"/>
-                <a:sym typeface="Roboto Mono"/>
-              </a:rPr>
-              <a:t>github.com/deanl1982/llm101</a:t>
-            </a:r>
-          </a:p>
-          <a:p>
-            <a:pPr lvl="0" algn="ctr"/>
-            <a:endParaRPr lang="en-GB" sz="800" dirty="0">
-              <a:latin typeface="Roboto Mono"/>
-              <a:ea typeface="Roboto Mono"/>
-              <a:cs typeface="Roboto Mono"/>
-              <a:sym typeface="Roboto Mono"/>
-            </a:endParaRPr>
-          </a:p>
-        </p:txBody>
-      </p:sp>
-      <p:sp>
-        <p:nvSpPr>
-          <p:cNvPr id="75" name="Google Shape;75;p15"/>
-          <p:cNvSpPr txBox="1"/>
-          <p:nvPr/>
-        </p:nvSpPr>
-        <p:spPr>
-          <a:xfrm>
-            <a:off x="427025" y="2138650"/>
-            <a:ext cx="8365500" cy="377700"/>
-          </a:xfrm>
-          <a:prstGeom prst="rect">
-            <a:avLst/>
-          </a:prstGeom>
-          <a:noFill/>
-          <a:ln>
-            <a:noFill/>
-          </a:ln>
-        </p:spPr>
-        <p:txBody>
-          <a:bodyPr spcFirstLastPara="1" wrap="square" lIns="91425" tIns="91425" rIns="91425" bIns="91425" anchor="t" anchorCtr="0">
-            <a:noAutofit/>
-          </a:bodyPr>
-          <a:lstStyle/>
-          <a:p>
-            <a:pPr marL="0" lvl="0" indent="0" algn="l" rtl="0">
-              <a:spcBef>
-                <a:spcPts val="0"/>
-              </a:spcBef>
-              <a:spcAft>
-                <a:spcPts val="0"/>
-              </a:spcAft>
-              <a:buNone/>
-            </a:pPr>
-            <a:r>
-              <a:rPr lang="en-GB" sz="1200" b="1" i="1">
-                <a:latin typeface="Roboto Mono"/>
-                <a:ea typeface="Roboto Mono"/>
-                <a:cs typeface="Roboto Mono"/>
-                <a:sym typeface="Roboto Mono"/>
-              </a:rPr>
-              <a:t>ai-101</a:t>
-            </a:r>
-            <a:endParaRPr sz="1200" b="1" i="1">
-              <a:solidFill>
-                <a:schemeClr val="dk2"/>
-              </a:solidFill>
-              <a:latin typeface="Roboto Mono"/>
-              <a:ea typeface="Roboto Mono"/>
-              <a:cs typeface="Roboto Mono"/>
-              <a:sym typeface="Roboto Mono"/>
-            </a:endParaRPr>
-          </a:p>
-        </p:txBody>
-      </p:sp>
     </p:spTree>
   </p:cSld>
   <p:clrMapOvr>
@@ -11344,9 +11284,9 @@
         <p:grpSpPr>
           <a:xfrm>
             <a:off x="313775" y="407600"/>
-            <a:ext cx="8478750" cy="4660725"/>
+            <a:ext cx="8579307" cy="4660725"/>
             <a:chOff x="313775" y="407600"/>
-            <a:chExt cx="8478750" cy="4660725"/>
+            <a:chExt cx="8579307" cy="4660725"/>
           </a:xfrm>
         </p:grpSpPr>
         <p:sp>
@@ -11842,6 +11782,70 @@
                 <a:t>ai-101</a:t>
               </a:r>
               <a:endParaRPr sz="1200" b="1" i="1">
+                <a:solidFill>
+                  <a:schemeClr val="dk2"/>
+                </a:solidFill>
+                <a:latin typeface="Roboto Mono"/>
+                <a:ea typeface="Roboto Mono"/>
+                <a:cs typeface="Roboto Mono"/>
+                <a:sym typeface="Roboto Mono"/>
+              </a:endParaRPr>
+            </a:p>
+          </p:txBody>
+        </p:sp>
+        <p:sp>
+          <p:nvSpPr>
+            <p:cNvPr id="2" name="Google Shape;92;p17">
+              <a:extLst>
+                <a:ext uri="{FF2B5EF4-FFF2-40B4-BE49-F238E27FC236}">
+                  <a16:creationId xmlns:a16="http://schemas.microsoft.com/office/drawing/2014/main" id="{FFE71EAE-912C-3ACC-329D-7D7AFCF3AB03}"/>
+                </a:ext>
+              </a:extLst>
+            </p:cNvPr>
+            <p:cNvSpPr txBox="1"/>
+            <p:nvPr/>
+          </p:nvSpPr>
+          <p:spPr>
+            <a:xfrm>
+              <a:off x="527582" y="408051"/>
+              <a:ext cx="8365500" cy="2219100"/>
+            </a:xfrm>
+            <a:prstGeom prst="rect">
+              <a:avLst/>
+            </a:prstGeom>
+            <a:noFill/>
+            <a:ln>
+              <a:noFill/>
+            </a:ln>
+          </p:spPr>
+          <p:txBody>
+            <a:bodyPr spcFirstLastPara="1" wrap="square" lIns="91425" tIns="91425" rIns="91425" bIns="91425" anchor="t" anchorCtr="0">
+              <a:noAutofit/>
+            </a:bodyPr>
+            <a:lstStyle/>
+            <a:p>
+              <a:pPr marL="0" lvl="0" indent="0" algn="r" rtl="0">
+                <a:spcBef>
+                  <a:spcPts val="0"/>
+                </a:spcBef>
+                <a:spcAft>
+                  <a:spcPts val="0"/>
+                </a:spcAft>
+                <a:buNone/>
+              </a:pPr>
+              <a:r>
+                <a:rPr lang="en-GB" b="1" i="1" dirty="0">
+                  <a:solidFill>
+                    <a:schemeClr val="dk2"/>
+                  </a:solidFill>
+                  <a:latin typeface="Roboto Mono"/>
+                  <a:ea typeface="Roboto Mono"/>
+                  <a:cs typeface="Roboto Mono"/>
+                  <a:sym typeface="Roboto Mono"/>
+                </a:rPr>
+                <a:t>“context turns data into knowledge”</a:t>
+              </a:r>
+              <a:endParaRPr b="1" i="1" dirty="0">
                 <a:solidFill>
                   <a:schemeClr val="dk2"/>
                 </a:solidFill>

</xml_diff>